<commit_message>
feat(rag): 실 e5 Embedding 검증 반영과 임계값 보정
- intfloat/multilingual-e5-small 실모델로 재색인·전체 테스트 통과(37건), 실모델 전용 테스트 추가
- RAG_SCORE_THRESHOLD 기본값 0.80 → 0.855 (샘플 매뉴얼 기준 관련 ≥0.876 / 무관 ≤0.833 중간값)
- 검색 청크의 Markdown 제목·인용 기호 제거, 출처·본문 줄 분리, UI에서 물결표(~) 취소선 렌더링 방지
- README·PPT의 Embedding 검증 현황 갱신, 캡처 재생성

Co-Authored-By: Claude Opus 5.5 <noreply@anthropic.com>
Claude-Session: https://claude.ai/code/session_01KjhWjRZVvzeYVaKYPHWciA
</commit_message>
<xml_diff>
--- a/docs/발표자료.pptx
+++ b/docs/발표자료.pptx
@@ -4981,7 +4981,7 @@
                 <a:ea typeface="Malgun Gothic"/>
                 <a:cs typeface="Malgun Gothic"/>
               </a:rPr>
-              <a:t>36 passed in 5.35s</a:t>
+              <a:t>37 passed in 16.64s</a:t>
             </a:r>
           </a:p>
         </p:txBody>
@@ -5058,7 +5058,7 @@
                 <a:ea typeface="Malgun Gothic"/>
                 <a:cs typeface="Malgun Gothic"/>
               </a:rPr>
-              <a:t>• test_rag: 샘플 질의 3건 출처 반환, 무관 질의 '문서 근거 없음'</a:t>
+              <a:t>• test_rag: 실 e5 Embedding으로 샘플 질의 3건 출처 반환, 무관 질의 '문서 근거 없음'</a:t>
             </a:r>
           </a:p>
           <a:p>
@@ -5217,7 +5217,7 @@
                 <a:ea typeface="Malgun Gothic"/>
                 <a:cs typeface="Malgun Gothic"/>
               </a:rPr>
-              <a:t>sentence-transformers 실 Embedding — 개발 환경 네트워크 정책으로 모델 다운로드 불가, 해싱 폴백으로 검증</a:t>
+              <a:t>실 Embedding은 검증 완료(e5-small): 관련 질의 top 유사도 ≥ 0.876, 무관 질의 ≤ 0.833 → 임계값 0.855 (샘플 문서 7청크 기준)</a:t>
             </a:r>
           </a:p>
           <a:p>
@@ -6002,7 +6002,7 @@
                 <a:ea typeface="Malgun Gothic"/>
                 <a:cs typeface="Malgun Gothic"/>
               </a:rPr>
-              <a:t>해싱 폴백은 어휘 겹침 기반, 임계값 미튜닝</a:t>
+              <a:t>임계값 0.855는 샘플 문서 7청크로만 보정</a:t>
             </a:r>
           </a:p>
         </p:txBody>
@@ -6091,7 +6091,7 @@
                 <a:ea typeface="Malgun Gothic"/>
                 <a:cs typeface="Malgun Gothic"/>
               </a:rPr>
-              <a:t>→ 실 Embedding 기준 임계값 튜닝, 공식 매뉴얼 색인</a:t>
+              <a:t>→ 공식 매뉴얼 색인 후 질의셋으로 임계값 재보정</a:t>
             </a:r>
           </a:p>
         </p:txBody>
@@ -11841,7 +11841,7 @@
                 <a:ea typeface="Malgun Gothic"/>
                 <a:cs typeface="Malgun Gothic"/>
               </a:rPr>
-              <a:t>EMBEDDING_MODEL=BAAI/bge-m3 전환 가능</a:t>
+              <a:t>EMBEDDING_MODEL=BAAI/bge-m3 전환 가능 · 기본 임계값 0.855(e5-small 보정값)</a:t>
             </a:r>
           </a:p>
           <a:p>

</xml_diff>